<commit_message>
Refresh the offline PDF and PPTX packs at 16:10.
These are the USB/backup slides for the talk if the live deck is unavailable.

Co-authored-by: rajbharsoutam <rajbharsoutam@gmail.com>
</commit_message>
<xml_diff>
--- a/Mtech presentation/The-Engineering-of-Play.pptx
+++ b/Mtech presentation/The-Engineering-of-Play.pptx
@@ -24,8 +24,8 @@
   <p:notesMasterIdLst>
     <p:notesMasterId r:id="rId17"/>
   </p:notesMasterIdLst>
-  <p:sldSz cx="12191695" cy="6858000"/>
-  <p:notesSz cx="6858000" cy="12191695"/>
+  <p:sldSz cx="12191695" cy="7619695"/>
+  <p:notesSz cx="7619695" cy="12191695"/>
   <p:defaultTextStyle>
     <a:lvl1pPr marL="0" algn="l" defTabSz="914400" rtl="0" eaLnBrk="1" latinLnBrk="0" hangingPunct="1">
       <a:defRPr sz="1800" kern="1200">
@@ -2131,7 +2131,7 @@
         <p:spPr>
           <a:xfrm>
             <a:off x="0" y="0"/>
-            <a:ext cx="12191695" cy="6858000"/>
+            <a:ext cx="12191695" cy="7619695"/>
           </a:xfrm>
           <a:prstGeom prst="rect">
             <a:avLst/>
@@ -2180,7 +2180,7 @@
         <p:spPr>
           <a:xfrm>
             <a:off x="0" y="0"/>
-            <a:ext cx="12191695" cy="6858000"/>
+            <a:ext cx="12191695" cy="7619695"/>
           </a:xfrm>
           <a:prstGeom prst="rect">
             <a:avLst/>
@@ -2229,7 +2229,7 @@
         <p:spPr>
           <a:xfrm>
             <a:off x="0" y="0"/>
-            <a:ext cx="12191695" cy="6858000"/>
+            <a:ext cx="12191695" cy="7619695"/>
           </a:xfrm>
           <a:prstGeom prst="rect">
             <a:avLst/>
@@ -2278,7 +2278,7 @@
         <p:spPr>
           <a:xfrm>
             <a:off x="0" y="0"/>
-            <a:ext cx="12191695" cy="6858000"/>
+            <a:ext cx="12191695" cy="7619695"/>
           </a:xfrm>
           <a:prstGeom prst="rect">
             <a:avLst/>
@@ -2327,7 +2327,7 @@
         <p:spPr>
           <a:xfrm>
             <a:off x="0" y="0"/>
-            <a:ext cx="12191695" cy="6858000"/>
+            <a:ext cx="12191695" cy="7619695"/>
           </a:xfrm>
           <a:prstGeom prst="rect">
             <a:avLst/>
@@ -2376,7 +2376,7 @@
         <p:spPr>
           <a:xfrm>
             <a:off x="0" y="0"/>
-            <a:ext cx="12191695" cy="6858000"/>
+            <a:ext cx="12191695" cy="7619695"/>
           </a:xfrm>
           <a:prstGeom prst="rect">
             <a:avLst/>
@@ -2425,7 +2425,7 @@
         <p:spPr>
           <a:xfrm>
             <a:off x="0" y="0"/>
-            <a:ext cx="12191695" cy="6858000"/>
+            <a:ext cx="12191695" cy="7619695"/>
           </a:xfrm>
           <a:prstGeom prst="rect">
             <a:avLst/>
@@ -2474,7 +2474,7 @@
         <p:spPr>
           <a:xfrm>
             <a:off x="0" y="0"/>
-            <a:ext cx="12191695" cy="6858000"/>
+            <a:ext cx="12191695" cy="7619695"/>
           </a:xfrm>
           <a:prstGeom prst="rect">
             <a:avLst/>
@@ -2523,7 +2523,7 @@
         <p:spPr>
           <a:xfrm>
             <a:off x="0" y="0"/>
-            <a:ext cx="12191695" cy="6858000"/>
+            <a:ext cx="12191695" cy="7619695"/>
           </a:xfrm>
           <a:prstGeom prst="rect">
             <a:avLst/>
@@ -2572,7 +2572,7 @@
         <p:spPr>
           <a:xfrm>
             <a:off x="0" y="0"/>
-            <a:ext cx="12191695" cy="6858000"/>
+            <a:ext cx="12191695" cy="7619695"/>
           </a:xfrm>
           <a:prstGeom prst="rect">
             <a:avLst/>
@@ -2621,7 +2621,7 @@
         <p:spPr>
           <a:xfrm>
             <a:off x="0" y="0"/>
-            <a:ext cx="12191695" cy="6858000"/>
+            <a:ext cx="12191695" cy="7619695"/>
           </a:xfrm>
           <a:prstGeom prst="rect">
             <a:avLst/>
@@ -2670,7 +2670,7 @@
         <p:spPr>
           <a:xfrm>
             <a:off x="0" y="0"/>
-            <a:ext cx="12191695" cy="6858000"/>
+            <a:ext cx="12191695" cy="7619695"/>
           </a:xfrm>
           <a:prstGeom prst="rect">
             <a:avLst/>
@@ -2719,7 +2719,7 @@
         <p:spPr>
           <a:xfrm>
             <a:off x="0" y="0"/>
-            <a:ext cx="12191695" cy="6858000"/>
+            <a:ext cx="12191695" cy="7619695"/>
           </a:xfrm>
           <a:prstGeom prst="rect">
             <a:avLst/>
@@ -2768,7 +2768,7 @@
         <p:spPr>
           <a:xfrm>
             <a:off x="0" y="0"/>
-            <a:ext cx="12191695" cy="6858000"/>
+            <a:ext cx="12191695" cy="7619695"/>
           </a:xfrm>
           <a:prstGeom prst="rect">
             <a:avLst/>
@@ -2817,7 +2817,7 @@
         <p:spPr>
           <a:xfrm>
             <a:off x="0" y="0"/>
-            <a:ext cx="12191695" cy="6858000"/>
+            <a:ext cx="12191695" cy="7619695"/>
           </a:xfrm>
           <a:prstGeom prst="rect">
             <a:avLst/>

</xml_diff>